<commit_message>
fix: the same corrections in the case deck, the docs and the Slack message
The verification covered the summary deck only. An audit for the same stale
claims across every artifact found three files still carrying them: the
24-slide case deck (ECDSA median CVE lag printed as 16 not 16.5, and the
unqualified 'every CVE nearest a spike is a validator bug'), and the docs
and Slack message ('every TLD that had them' -- .gov never collapsed -- and
the unreproducible 97% release density, now recomputed as 95% of the 210
months from 2009-03 to 2026-08).

Co-Authored-By: Claude Opus 5 (1M context) <noreply@anthropic.com>
Claude-Session: https://claude.ai/code/session_01JM7zyy7DyMdzKZZxhHrRfK
</commit_message>
<xml_diff>
--- a/out/analysis/dnssec_program_rfc_cases.pptx
+++ b/out/analysis/dnssec_program_rfc_cases.pptx
@@ -10454,7 +10454,7 @@
                 </a:solidFill>
                 <a:latin typeface="Segoe UI"/>
               </a:rPr>
-              <a:t>97% of months contain some DNS release, so 'a release came shortly before' is always true. Each lag is compared with the same lag at every month of the series: the chance rate. A spike is release-timed only if it beats that.</a:t>
+              <a:t>95% of months contain some DNS release, so 'a release came shortly before' is always true. Each lag is compared with the same lag at every month of the series: the chance rate. A spike is release-timed only if it beats that.</a:t>
             </a:r>
           </a:p>
         </p:txBody>
@@ -13008,7 +13008,7 @@
                 </a:solidFill>
                 <a:latin typeface="Segoe UI"/>
               </a:rPr>
-              <a:t>CVEs did not lead any push. Every CVE nearest to a spike is a validator bug (memory leak, assertion failure); the one CVE that sits inside a causal chain, CVE-2021-40083, is a symptom of the same iteration problem the caps fixed. Median lag from a spike to the nearest CVE: 16 months for ECDSA, 57 for NSEC3.</a:t>
+              <a:t>CVEs did not lead any push. Every CVE nearest to a spike is a validator bug (memory leak, assertion failure); the one CVE that sits inside a causal chain, CVE-2021-40083, is a symptom of the same iteration problem the caps fixed. Median lag from a spike to the nearest CVE: 16.5 months for ECDSA, 57 for NSEC3. Most are resolver bugs, but CVE-2014-0591, nearest to 16 of the NSEC3 spikes, is an assertion failure in BIND's authoritative NSEC3 code.</a:t>
             </a:r>
           </a:p>
         </p:txBody>

</xml_diff>